<commit_message>
data(resultados): entregáveis regenerados após a releitura E8.7 (04/10/2026)
Norma 27/27, Word 49 páginas, fósseis 0, números sem fonte 0, verificar_analises 0 ALTO.

Co-Authored-By: Claude Opus 5.5 (1M context) <noreply@anthropic.com>
Claude-Session: https://claude.ai/code/session_01ATPBca6o9jxRv5wGBtSSkf
</commit_message>
<xml_diff>
--- a/entregaveis/TCC_Ricardo_Calheiros_Defesa.pptx
+++ b/entregaveis/TCC_Ricardo_Calheiros_Defesa.pptx
@@ -7899,7 +7899,7 @@
                 </a:solidFill>
                 <a:latin typeface="Calibri"/>
               </a:rPr>
-              <a:t>À esquerda, o acesso (GLMM por grupo); à direita, o salário (Oaxaca-Blinder vs. homem branco) | em log-pontos, gap dela 0,592 &lt; soma 0,629: as desvantagens se acumulam</a:t>
+              <a:t>Esquerda: acesso (GLMM); direita: salário (Oaxaca vs. homem branco) | gap dela 0,592 &lt; soma 0,629 log-pontos: desvantagens se acumulam</a:t>
             </a:r>
           </a:p>
         </p:txBody>
@@ -9486,7 +9486,7 @@
                 </a:solidFill>
                 <a:latin typeface="Calibri"/>
               </a:rPr>
-              <a:t>Pretos: penalidade maior em tudo — salário 7,4% contra 5,8% dos pardos; no topo, a distância cresce (q95: 11,6% × 9,5%)</a:t>
+              <a:t>Pretos: penalidade maior em todas as medidas — salário 7,4% contra 5,8% dos pardos; no 9º decil da renda, a distância cresce (10,0% × 8,0%)</a:t>
             </a:r>
           </a:p>
           <a:p>
@@ -9536,7 +9536,7 @@
                 </a:solidFill>
                 <a:latin typeface="Calibri"/>
               </a:rPr>
-              <a:t>Idade: de 1,7% a 14,7% — coorte ou carreira</a:t>
+              <a:t>Idade: de 1,7% a 14,7% — carreira ou geração (o dado não separa)</a:t>
             </a:r>
           </a:p>
           <a:p>
@@ -9561,7 +9561,7 @@
                 </a:solidFill>
                 <a:latin typeface="Calibri"/>
               </a:rPr>
-              <a:t>Teto de vidro dentro de cada UF: OR 0,762 (não é efeito da geografia)</a:t>
+              <a:t>Teto de vidro dentro de cada UF: OR 0,762 (não decorre da geografia dos salários)</a:t>
             </a:r>
           </a:p>
         </p:txBody>
@@ -9596,14 +9596,49 @@
                 </a:solidFill>
                 <a:latin typeface="Calibri"/>
               </a:rPr>
-              <a:t>"Negro" segue como a categoria da política: pretos e pardos estão abaixo dos brancos em tudo.</a:t>
-            </a:r>
-          </a:p>
-        </p:txBody>
-      </p:sp>
-      <p:sp>
-        <p:nvSpPr>
-          <p:cNvPr id="8" name="Rectangle 7"/>
+              <a:t>"Negro" segue como a categoria da política: pretos e pardos estão abaixo dos brancos em todas as medidas.</a:t>
+            </a:r>
+          </a:p>
+        </p:txBody>
+      </p:sp>
+      <p:sp>
+        <p:nvSpPr>
+          <p:cNvPr id="8" name="TextBox 7"/>
+          <p:cNvSpPr txBox="1"/>
+          <p:nvPr/>
+        </p:nvSpPr>
+        <p:spPr>
+          <a:xfrm>
+            <a:off x="274320" y="6355080"/>
+            <a:ext cx="11612880" cy="274320"/>
+          </a:xfrm>
+          <a:prstGeom prst="rect">
+            <a:avLst/>
+          </a:prstGeom>
+          <a:noFill/>
+        </p:spPr>
+        <p:txBody>
+          <a:bodyPr wrap="square">
+            <a:spAutoFit/>
+          </a:bodyPr>
+          <a:lstStyle/>
+          <a:p>
+            <a:pPr algn="ctr"/>
+            <a:r>
+              <a:rPr sz="1000" b="0" i="0">
+                <a:solidFill>
+                  <a:srgbClr val="1F3864"/>
+                </a:solidFill>
+                <a:latin typeface="Calibri"/>
+              </a:rPr>
+              <a:t>OR &lt; 1 = menor chance que um branco de mesmo perfil e bairro. Fonte: PNAD Contínua 2016–2025, população completa.</a:t>
+            </a:r>
+          </a:p>
+        </p:txBody>
+      </p:sp>
+      <p:sp>
+        <p:nvSpPr>
+          <p:cNvPr id="9" name="Rectangle 8"/>
           <p:cNvSpPr/>
           <p:nvPr/>
         </p:nvSpPr>
@@ -9644,7 +9679,7 @@
       </p:sp>
       <p:sp>
         <p:nvSpPr>
-          <p:cNvPr id="9" name="TextBox 8"/>
+          <p:cNvPr id="10" name="TextBox 9"/>
           <p:cNvSpPr txBox="1"/>
           <p:nvPr/>
         </p:nvSpPr>
@@ -9679,7 +9714,7 @@
       </p:sp>
       <p:sp>
         <p:nvSpPr>
-          <p:cNvPr id="10" name="TextBox 9"/>
+          <p:cNvPr id="11" name="TextBox 10"/>
           <p:cNvSpPr txBox="1"/>
           <p:nvPr/>
         </p:nvSpPr>

</xml_diff>

<commit_message>
data(resultados): entregáveis conforme o Relatório de Formatação (06/10/2026)
Norma 31/31, Word 49 páginas, fósseis 0, números sem fonte 0, validate consistente.

Co-Authored-By: Claude Opus 5.5 (1M context) <noreply@anthropic.com>
Claude-Session: https://claude.ai/code/session_01ATPBca6o9jxRv5wGBtSSkf
</commit_message>
<xml_diff>
--- a/entregaveis/TCC_Ricardo_Calheiros_Defesa.pptx
+++ b/entregaveis/TCC_Ricardo_Calheiros_Defesa.pptx
@@ -4365,7 +4365,7 @@
         <p:spPr>
           <a:xfrm>
             <a:off x="274320" y="1188720"/>
-            <a:ext cx="7772400" cy="3123177"/>
+            <a:ext cx="7772400" cy="2436266"/>
           </a:xfrm>
           <a:prstGeom prst="rect">
             <a:avLst/>
@@ -4879,7 +4879,7 @@
         <p:spPr>
           <a:xfrm>
             <a:off x="274320" y="1097280"/>
-            <a:ext cx="6400800" cy="2970187"/>
+            <a:ext cx="6400800" cy="2334194"/>
           </a:xfrm>
           <a:prstGeom prst="rect">
             <a:avLst/>
@@ -5722,7 +5722,7 @@
         <p:spPr>
           <a:xfrm>
             <a:off x="274320" y="1097280"/>
-            <a:ext cx="6949440" cy="4877520"/>
+            <a:ext cx="6949440" cy="4073404"/>
           </a:xfrm>
           <a:prstGeom prst="rect">
             <a:avLst/>
@@ -6471,7 +6471,7 @@
         <p:spPr>
           <a:xfrm>
             <a:off x="274320" y="1097280"/>
-            <a:ext cx="11612880" cy="4198242"/>
+            <a:ext cx="11612880" cy="3363590"/>
           </a:xfrm>
           <a:prstGeom prst="rect">
             <a:avLst/>
@@ -23278,7 +23278,7 @@
         <p:spPr>
           <a:xfrm>
             <a:off x="502920" y="1097280"/>
-            <a:ext cx="7052567" cy="3154680"/>
+            <a:ext cx="7187674" cy="3154680"/>
           </a:xfrm>
           <a:prstGeom prst="rect">
             <a:avLst/>

</xml_diff>

<commit_message>
data(resultados): entregáveis com o novo título (06/10/2026)
Norma 31/31, Word 49 páginas, fósseis 0, números sem fonte 0, validate consistente.

Co-Authored-By: Claude Opus 5.5 (1M context) <noreply@anthropic.com>
Claude-Session: https://claude.ai/code/session_01ATPBca6o9jxRv5wGBtSSkf
</commit_message>
<xml_diff>
--- a/entregaveis/TCC_Ricardo_Calheiros_Defesa.pptx
+++ b/entregaveis/TCC_Ricardo_Calheiros_Defesa.pptx
@@ -3222,13 +3222,13 @@
           <a:p>
             <a:pPr algn="ctr"/>
             <a:r>
-              <a:rPr sz="3200" b="1" i="0">
+              <a:rPr sz="3000" b="1" i="0">
                 <a:solidFill>
                   <a:srgbClr val="FFFFFF"/>
                 </a:solidFill>
                 <a:latin typeface="Calibri"/>
               </a:rPr>
-              <a:t>Racismo Estrutural e Mercado de Trabalho no Brasil</a:t>
+              <a:t>Bairro, porta e topo: o racismo estrutural no mercado de trabalho brasileiro</a:t>
             </a:r>
           </a:p>
         </p:txBody>

</xml_diff>